<commit_message>
Sample proposal v2: full 16-page Technical Volume + complete deck/cost + canvas templates
- Technical Volume expanded to a genuine full-length SBIR volume (15 numbered
  sections + 2 appendices, 12pt/1.5): added §2.6 Model Architecture, §2.7
  Robustness, expanded §1 (operational requirements + why-now), §14 IP & Data
  Rights, §15 Broader Impacts, 2nd figure (inference pipeline), more tables.
  Authoritative page count (pdfjs-dist): 16 pages docx + pdf.
- Commercialization: 5 complete slides. Cost Volume: 2 tabs (Direct-Labor detail
  + Budget Summary), currency + subtotals, $150,000 total.
- docs/sample-proposal/canvas/*.canvas.json — each deliverable's source
  CanvasDocument saved as a reusable example template.
- README reframed as canonical example outputs/templates.

Generated by frontend/scripts/gen-sample-proposal.mts (real exporters). tsc 0.

Co-Authored-By: Claude Opus 4.8 <noreply@anthropic.com>
Claude-Session: https://claude.ai/code/session_014WpKLE6LTPMraFbTacbbBV
</commit_message>
<xml_diff>
--- a/docs/sample-proposal/Aerivio_Commercialization.pptx
+++ b/docs/sample-proposal/Aerivio_Commercialization.pptx
@@ -1341,6 +1341,45 @@
           </a:p>
         </p:txBody>
       </p:sp>
+      <p:sp>
+        <p:nvSpPr>
+          <p:cNvPr id="5" name="Text 3"/>
+          <p:cNvSpPr/>
+          <p:nvPr/>
+        </p:nvSpPr>
+        <p:spPr>
+          <a:xfrm>
+            <a:off x="457200" y="2286000"/>
+            <a:ext cx="11274552" cy="365760"/>
+          </a:xfrm>
+          <a:prstGeom prst="rect">
+            <a:avLst/>
+          </a:prstGeom>
+          <a:noFill/>
+          <a:ln/>
+        </p:spPr>
+        <p:txBody>
+          <a:bodyPr wrap="square" rtlCol="0" anchor="t"/>
+          <a:lstStyle/>
+          <a:p>
+            <a:pPr indent="0" marL="0">
+              <a:buNone/>
+            </a:pPr>
+            <a:r>
+              <a:rPr lang="en-US" sz="1800" dirty="0">
+                <a:solidFill>
+                  <a:srgbClr val="444444"/>
+                </a:solidFill>
+                <a:latin typeface="Arial" pitchFamily="34" charset="0"/>
+                <a:ea typeface="Arial" pitchFamily="34" charset="-122"/>
+                <a:cs typeface="Arial" pitchFamily="34" charset="-120"/>
+              </a:rPr>
+              <a:t>Topic N251-042 · US Navy · $150,000 / 6 months</a:t>
+            </a:r>
+            <a:endParaRPr lang="en-US" sz="1800" dirty="0"/>
+          </a:p>
+        </p:txBody>
+      </p:sp>
     </p:spTree>
   </p:cSld>
   <p:clrMapOvr>
@@ -1414,7 +1453,7 @@
         <p:spPr>
           <a:xfrm>
             <a:off x="457200" y="1371600"/>
-            <a:ext cx="11274552" cy="960120"/>
+            <a:ext cx="11274552" cy="1280160"/>
           </a:xfrm>
           <a:prstGeom prst="rect">
             <a:avLst/>
@@ -1439,7 +1478,7 @@
                 <a:ea typeface="Arial" pitchFamily="34" charset="-122"/>
                 <a:cs typeface="Arial" pitchFamily="34" charset="-120"/>
               </a:rPr>
-              <a:t>Navy USV fleet projected to exceed 300 hulls by 2030</a:t>
+              <a:t>Navy USV fleet projected to exceed 300 hulls by 2030 — each needs edge acoustic sensing</a:t>
             </a:r>
             <a:endParaRPr lang="en-US" sz="1800" dirty="0"/>
           </a:p>
@@ -1457,7 +1496,7 @@
                 <a:ea typeface="Arial" pitchFamily="34" charset="-122"/>
                 <a:cs typeface="Arial" pitchFamily="34" charset="-120"/>
               </a:rPr>
-              <a:t>Every autonomous hull needs edge acoustic sensing</a:t>
+              <a:t>Beachhead: US Navy programs of record</a:t>
             </a:r>
             <a:endParaRPr lang="en-US" sz="1800" dirty="0"/>
           </a:p>
@@ -1475,7 +1514,25 @@
                 <a:ea typeface="Arial" pitchFamily="34" charset="-122"/>
                 <a:cs typeface="Arial" pitchFamily="34" charset="-120"/>
               </a:rPr>
-              <a:t>Beachhead: Navy; expansion: allied navies + commercial maritime security</a:t>
+              <a:t>Expansion: allied navies + commercial maritime security (ports, offshore energy)</a:t>
+            </a:r>
+            <a:endParaRPr lang="en-US" sz="1800" dirty="0"/>
+          </a:p>
+          <a:p>
+            <a:pPr marL="342900" indent="-342900">
+              <a:buSzPct val="100000"/>
+              <a:buChar char="•"/>
+            </a:pPr>
+            <a:r>
+              <a:rPr lang="en-US" sz="1800" dirty="0">
+                <a:solidFill>
+                  <a:srgbClr val="444444"/>
+                </a:solidFill>
+                <a:latin typeface="Arial" pitchFamily="34" charset="0"/>
+                <a:ea typeface="Arial" pitchFamily="34" charset="-122"/>
+                <a:cs typeface="Arial" pitchFamily="34" charset="-120"/>
+              </a:rPr>
+              <a:t>Serviceable market growing ~$8M → $60M+ per year by 2030</a:t>
             </a:r>
             <a:endParaRPr lang="en-US" sz="1800" dirty="0"/>
           </a:p>
@@ -1489,7 +1546,7 @@
         </p:nvSpPr>
         <p:spPr>
           <a:xfrm>
-            <a:off x="457200" y="2423160"/>
+            <a:off x="457200" y="2743200"/>
             <a:ext cx="11274552" cy="365760"/>
           </a:xfrm>
           <a:prstGeom prst="rect">
@@ -1593,7 +1650,7 @@
         <p:spPr>
           <a:xfrm>
             <a:off x="457200" y="1371600"/>
-            <a:ext cx="11274552" cy="960120"/>
+            <a:ext cx="11274552" cy="1280160"/>
           </a:xfrm>
           <a:prstGeom prst="rect">
             <a:avLst/>
@@ -1618,7 +1675,7 @@
                 <a:ea typeface="Arial" pitchFamily="34" charset="-122"/>
                 <a:cs typeface="Arial" pitchFamily="34" charset="-120"/>
               </a:rPr>
-              <a:t>Incumbents process acoustics shore-side (latency, comms-dependent)</a:t>
+              <a:t>Incumbents process acoustics shore-side → latency + comms dependence</a:t>
             </a:r>
             <a:endParaRPr lang="en-US" sz="1800" dirty="0"/>
           </a:p>
@@ -1636,7 +1693,7 @@
                 <a:ea typeface="Arial" pitchFamily="34" charset="-122"/>
                 <a:cs typeface="Arial" pitchFamily="34" charset="-120"/>
               </a:rPr>
-              <a:t>Aerivio runs fully on-vessel at 2 watts</a:t>
+              <a:t>Aerivio runs fully on-vessel at 2 watts, &lt;100 ms</a:t>
             </a:r>
             <a:endParaRPr lang="en-US" sz="1800" dirty="0"/>
           </a:p>
@@ -1655,6 +1712,91 @@
                 <a:cs typeface="Arial" pitchFamily="34" charset="-120"/>
               </a:rPr>
               <a:t>Defensible IP: saliency-guided quantization pipeline (patent pending)</a:t>
+            </a:r>
+            <a:endParaRPr lang="en-US" sz="1800" dirty="0"/>
+          </a:p>
+          <a:p>
+            <a:pPr marL="342900" indent="-342900">
+              <a:buSzPct val="100000"/>
+              <a:buChar char="•"/>
+            </a:pPr>
+            <a:r>
+              <a:rPr lang="en-US" sz="1800" dirty="0">
+                <a:solidFill>
+                  <a:srgbClr val="444444"/>
+                </a:solidFill>
+                <a:latin typeface="Arial" pitchFamily="34" charset="0"/>
+                <a:ea typeface="Arial" pitchFamily="34" charset="-122"/>
+                <a:cs typeface="Arial" pitchFamily="34" charset="-120"/>
+              </a:rPr>
+              <a:t>Retrofits deployed hulls — no new hardware program required</a:t>
+            </a:r>
+            <a:endParaRPr lang="en-US" sz="1800" dirty="0"/>
+          </a:p>
+        </p:txBody>
+      </p:sp>
+      <p:sp>
+        <p:nvSpPr>
+          <p:cNvPr id="4" name="Text 2"/>
+          <p:cNvSpPr/>
+          <p:nvPr/>
+        </p:nvSpPr>
+        <p:spPr>
+          <a:xfrm>
+            <a:off x="457200" y="2743200"/>
+            <a:ext cx="11274552" cy="548640"/>
+          </a:xfrm>
+          <a:prstGeom prst="rect">
+            <a:avLst/>
+          </a:prstGeom>
+          <a:noFill/>
+          <a:ln/>
+        </p:spPr>
+        <p:txBody>
+          <a:bodyPr wrap="square" rtlCol="0" anchor="t"/>
+          <a:lstStyle/>
+          <a:p>
+            <a:pPr indent="0" marL="0">
+              <a:buNone/>
+            </a:pPr>
+            <a:r>
+              <a:rPr lang="en-US" sz="1800" dirty="0">
+                <a:solidFill>
+                  <a:srgbClr val="444444"/>
+                </a:solidFill>
+                <a:latin typeface="Arial" pitchFamily="34" charset="0"/>
+                <a:ea typeface="Arial" pitchFamily="34" charset="-122"/>
+                <a:cs typeface="Arial" pitchFamily="34" charset="-120"/>
+              </a:rPr>
+              <a:t>Bottom line: we </a:t>
+            </a:r>
+            <a:pPr indent="0" marL="0">
+              <a:buNone/>
+            </a:pPr>
+            <a:r>
+              <a:rPr lang="en-US" sz="1800" b="1" dirty="0">
+                <a:solidFill>
+                  <a:srgbClr val="444444"/>
+                </a:solidFill>
+                <a:latin typeface="Arial" pitchFamily="34" charset="0"/>
+                <a:ea typeface="Arial" pitchFamily="34" charset="-122"/>
+                <a:cs typeface="Arial" pitchFamily="34" charset="-120"/>
+              </a:rPr>
+              <a:t>win where connectivity fails</a:t>
+            </a:r>
+            <a:pPr indent="0" marL="0">
+              <a:buNone/>
+            </a:pPr>
+            <a:r>
+              <a:rPr lang="en-US" sz="1800" dirty="0">
+                <a:solidFill>
+                  <a:srgbClr val="444444"/>
+                </a:solidFill>
+                <a:latin typeface="Arial" pitchFamily="34" charset="0"/>
+                <a:ea typeface="Arial" pitchFamily="34" charset="-122"/>
+                <a:cs typeface="Arial" pitchFamily="34" charset="-120"/>
+              </a:rPr>
+              <a:t> — exactly the contested environment that matters.</a:t>
             </a:r>
             <a:endParaRPr lang="en-US" sz="1800" dirty="0"/>
           </a:p>
@@ -1759,7 +1901,7 @@
                 <a:ea typeface="Arial" pitchFamily="34" charset="-122"/>
                 <a:cs typeface="Arial" pitchFamily="34" charset="-120"/>
               </a:rPr>
-              <a:t>Phase I: feasibility on Navy corpus (months 1–6)</a:t>
+              <a:t>Phase I (now): feasibility on the Navy corpus, months 1–6</a:t>
             </a:r>
             <a:endParaRPr lang="en-US" sz="1800" dirty="0"/>
           </a:p>
@@ -1778,7 +1920,7 @@
                 <a:ea typeface="Arial" pitchFamily="34" charset="-122"/>
                 <a:cs typeface="Arial" pitchFamily="34" charset="-120"/>
               </a:rPr>
-              <a:t>Phase II: hardened module + at-sea trials</a:t>
+              <a:t>Phase II: hardened module + at-sea demonstration (~$1.1M / 24 mo)</a:t>
             </a:r>
             <a:endParaRPr lang="en-US" sz="1800" dirty="0"/>
           </a:p>
@@ -1797,7 +1939,7 @@
                 <a:ea typeface="Arial" pitchFamily="34" charset="-122"/>
                 <a:cs typeface="Arial" pitchFamily="34" charset="-120"/>
               </a:rPr>
-              <a:t>Phase III: transition to PEO USC program of record</a:t>
+              <a:t>Phase III: transition to a Navy USV program of record</a:t>
             </a:r>
             <a:endParaRPr lang="en-US" sz="1800" dirty="0"/>
           </a:p>
@@ -1816,7 +1958,46 @@
                 <a:ea typeface="Arial" pitchFamily="34" charset="-122"/>
                 <a:cs typeface="Arial" pitchFamily="34" charset="-120"/>
               </a:rPr>
-              <a:t>Commercial: port-security &amp; offshore-energy monitoring</a:t>
+              <a:t>Commercial: port-security &amp; offshore-energy monitoring (dual-use)</a:t>
+            </a:r>
+            <a:endParaRPr lang="en-US" sz="1800" dirty="0"/>
+          </a:p>
+        </p:txBody>
+      </p:sp>
+      <p:sp>
+        <p:nvSpPr>
+          <p:cNvPr id="4" name="Text 2"/>
+          <p:cNvSpPr/>
+          <p:nvPr/>
+        </p:nvSpPr>
+        <p:spPr>
+          <a:xfrm>
+            <a:off x="457200" y="2743200"/>
+            <a:ext cx="11274552" cy="548640"/>
+          </a:xfrm>
+          <a:prstGeom prst="rect">
+            <a:avLst/>
+          </a:prstGeom>
+          <a:noFill/>
+          <a:ln/>
+        </p:spPr>
+        <p:txBody>
+          <a:bodyPr wrap="square" rtlCol="0" anchor="t"/>
+          <a:lstStyle/>
+          <a:p>
+            <a:pPr indent="0" marL="0">
+              <a:buNone/>
+            </a:pPr>
+            <a:r>
+              <a:rPr lang="en-US" sz="1800" dirty="0">
+                <a:solidFill>
+                  <a:srgbClr val="444444"/>
+                </a:solidFill>
+                <a:latin typeface="Arial" pitchFamily="34" charset="0"/>
+                <a:ea typeface="Arial" pitchFamily="34" charset="-122"/>
+                <a:cs typeface="Arial" pitchFamily="34" charset="-120"/>
+              </a:rPr>
+              <a:t>Transition is a software integration, not a hardware program — a low-barrier path to a funded home.</a:t>
             </a:r>
             <a:endParaRPr lang="en-US" sz="1800" dirty="0"/>
           </a:p>
@@ -1880,7 +2061,7 @@
                 <a:ea typeface="Arial" pitchFamily="34" charset="-122"/>
                 <a:cs typeface="Arial" pitchFamily="34" charset="-120"/>
               </a:rPr>
-              <a:t>Financials &amp; Ask</a:t>
+              <a:t>Financials &amp; The Ask</a:t>
             </a:r>
             <a:endParaRPr lang="en-US" sz="2800" dirty="0"/>
           </a:p>
@@ -1962,7 +2143,7 @@
         <p:spPr>
           <a:xfrm>
             <a:off x="457200" y="1828800"/>
-            <a:ext cx="11274552" cy="960120"/>
+            <a:ext cx="11274552" cy="1280160"/>
           </a:xfrm>
           <a:prstGeom prst="rect">
             <a:avLst/>
@@ -1987,7 +2168,7 @@
                 <a:ea typeface="Arial" pitchFamily="34" charset="-122"/>
                 <a:cs typeface="Arial" pitchFamily="34" charset="-120"/>
               </a:rPr>
-              <a:t>Team of 3 (PI + 2 engineers)</a:t>
+              <a:t>Team of 3 (PI + systems + ML engineer)</a:t>
             </a:r>
             <a:endParaRPr lang="en-US" sz="1800" dirty="0"/>
           </a:p>
@@ -2005,7 +2186,7 @@
                 <a:ea typeface="Arial" pitchFamily="34" charset="-122"/>
                 <a:cs typeface="Arial" pitchFamily="34" charset="-120"/>
               </a:rPr>
-              <a:t>Deliverable: validated 4-bit edge classifier</a:t>
+              <a:t>Deliverable: validated 4-bit edge classifier meeting all three gates</a:t>
             </a:r>
             <a:endParaRPr lang="en-US" sz="1800" dirty="0"/>
           </a:p>
@@ -2023,7 +2204,64 @@
                 <a:ea typeface="Arial" pitchFamily="34" charset="-122"/>
                 <a:cs typeface="Arial" pitchFamily="34" charset="-120"/>
               </a:rPr>
-              <a:t>Phase II target: $1.1M for at-sea demonstration</a:t>
+              <a:t>Phase II target: $1.1M for an at-sea demonstration</a:t>
+            </a:r>
+            <a:endParaRPr lang="en-US" sz="1800" dirty="0"/>
+          </a:p>
+          <a:p>
+            <a:pPr marL="342900" indent="-342900">
+              <a:buSzPct val="100000"/>
+              <a:buChar char="•"/>
+            </a:pPr>
+            <a:r>
+              <a:rPr lang="en-US" sz="1800" dirty="0">
+                <a:solidFill>
+                  <a:srgbClr val="444444"/>
+                </a:solidFill>
+                <a:latin typeface="Arial" pitchFamily="34" charset="0"/>
+                <a:ea typeface="Arial" pitchFamily="34" charset="-122"/>
+                <a:cs typeface="Arial" pitchFamily="34" charset="-120"/>
+              </a:rPr>
+              <a:t>Commercial revenue path reduces single-program reliance</a:t>
+            </a:r>
+            <a:endParaRPr lang="en-US" sz="1800" dirty="0"/>
+          </a:p>
+        </p:txBody>
+      </p:sp>
+      <p:sp>
+        <p:nvSpPr>
+          <p:cNvPr id="5" name="Text 3"/>
+          <p:cNvSpPr/>
+          <p:nvPr/>
+        </p:nvSpPr>
+        <p:spPr>
+          <a:xfrm>
+            <a:off x="457200" y="3200400"/>
+            <a:ext cx="11274552" cy="365760"/>
+          </a:xfrm>
+          <a:prstGeom prst="rect">
+            <a:avLst/>
+          </a:prstGeom>
+          <a:noFill/>
+          <a:ln/>
+        </p:spPr>
+        <p:txBody>
+          <a:bodyPr wrap="square" rtlCol="0" anchor="t"/>
+          <a:lstStyle/>
+          <a:p>
+            <a:pPr indent="0" marL="0">
+              <a:buNone/>
+            </a:pPr>
+            <a:r>
+              <a:rPr lang="en-US" sz="1800" dirty="0">
+                <a:solidFill>
+                  <a:srgbClr val="444444"/>
+                </a:solidFill>
+                <a:latin typeface="Arial" pitchFamily="34" charset="0"/>
+                <a:ea typeface="Arial" pitchFamily="34" charset="-122"/>
+                <a:cs typeface="Arial" pitchFamily="34" charset="-120"/>
+              </a:rPr>
+              <a:t>Ask: fund Phase I to de-risk the edge classifier and unlock the transition path.</a:t>
             </a:r>
             <a:endParaRPr lang="en-US" sz="1800" dirty="0"/>
           </a:p>

</xml_diff>